<commit_message>
docs: translate beehive slides to pt-br
</commit_message>
<xml_diff>
--- a/beehive-monitoring/beehive-monitoring-ac4-slides.pptx
+++ b/beehive-monitoring/beehive-monitoring-ac4-slides.pptx
@@ -3194,28 +3194,28 @@
         <p:spPr>
           <a:xfrm>
             <a:off x="658368" y="1645920"/>
-            <a:ext cx="7863840" cy="1325880"/>
-          </a:xfrm>
-          <a:prstGeom prst="rect">
-            <a:avLst/>
-          </a:prstGeom>
-          <a:noFill/>
-        </p:spPr>
-        <p:txBody>
-          <a:bodyPr wrap="square" lIns="36576" rIns="36576" tIns="36576" bIns="36576" anchor="t">
-            <a:spAutoFit/>
-          </a:bodyPr>
-          <a:lstStyle/>
-          <a:p>
-            <a:pPr algn="l"/>
-            <a:r>
-              <a:rPr sz="5600" b="1" i="0">
+            <a:ext cx="7863840" cy="1508760"/>
+          </a:xfrm>
+          <a:prstGeom prst="rect">
+            <a:avLst/>
+          </a:prstGeom>
+          <a:noFill/>
+        </p:spPr>
+        <p:txBody>
+          <a:bodyPr wrap="square" lIns="36576" rIns="36576" tIns="36576" bIns="36576" anchor="t">
+            <a:spAutoFit/>
+          </a:bodyPr>
+          <a:lstStyle/>
+          <a:p>
+            <a:pPr algn="l"/>
+            <a:r>
+              <a:rPr sz="5000" b="1" i="0">
                 <a:solidFill>
                   <a:srgbClr val="121418"/>
                 </a:solidFill>
                 <a:latin typeface="Arial"/>
               </a:rPr>
-              <a:t>Beehive Monitoring</a:t>
+              <a:t>Monitoramento de Colmeias</a:t>
             </a:r>
           </a:p>
         </p:txBody>
@@ -3228,8 +3228,8 @@
         </p:nvSpPr>
         <p:spPr>
           <a:xfrm>
-            <a:off x="658368" y="3063240"/>
-            <a:ext cx="7132320" cy="566928"/>
+            <a:off x="658368" y="3657600"/>
+            <a:ext cx="7132320" cy="713232"/>
           </a:xfrm>
           <a:prstGeom prst="rect">
             <a:avLst/>
@@ -3250,7 +3250,7 @@
                 </a:solidFill>
                 <a:latin typeface="Arial"/>
               </a:rPr>
-              <a:t>Six references that shape a low-cost, non-invasive monitoring system</a:t>
+              <a:t>Seis referências que orientam um sistema de baixo custo e não invasivo</a:t>
             </a:r>
           </a:p>
         </p:txBody>
@@ -3375,7 +3375,7 @@
                 </a:solidFill>
                 <a:latin typeface="Arial"/>
               </a:rPr>
-              <a:t>ENVIRONMENT</a:t>
+              <a:t>AMBIENTE</a:t>
             </a:r>
           </a:p>
         </p:txBody>
@@ -3455,7 +3455,7 @@
                 </a:solidFill>
                 <a:latin typeface="Arial"/>
               </a:rPr>
-              <a:t>ENTRANCE</a:t>
+              <a:t>ENTRADA</a:t>
             </a:r>
           </a:p>
         </p:txBody>
@@ -3535,7 +3535,7 @@
                 </a:solidFill>
                 <a:latin typeface="Arial"/>
               </a:rPr>
-              <a:t>ACOUSTICS + IoT</a:t>
+              <a:t>ACÚSTICA + IoT</a:t>
             </a:r>
           </a:p>
         </p:txBody>
@@ -3666,7 +3666,7 @@
                 </a:solidFill>
                 <a:latin typeface="Arial"/>
               </a:rPr>
-              <a:t>SOURCES</a:t>
+              <a:t>FONTES</a:t>
             </a:r>
           </a:p>
         </p:txBody>
@@ -3701,7 +3701,7 @@
                 </a:solidFill>
                 <a:latin typeface="Arial"/>
               </a:rPr>
-              <a:t>References used in the AC4 presentation</a:t>
+              <a:t>Referências usadas na apresentação da AC4</a:t>
             </a:r>
           </a:p>
         </p:txBody>
@@ -4296,7 +4296,7 @@
                 </a:solidFill>
                 <a:latin typeface="Arial"/>
               </a:rPr>
-              <a:t>Use the article's references.bib for the complete BibTeX records.</a:t>
+              <a:t>Consulte o references.bib do artigo para os registros BibTeX completos.</a:t>
             </a:r>
           </a:p>
         </p:txBody>
@@ -4376,7 +4376,7 @@
                 </a:solidFill>
                 <a:latin typeface="Arial"/>
               </a:rPr>
-              <a:t>Fontes: Publisher records, DOI pages and the open arXiv preprint listed above</a:t>
+              <a:t>Fontes: Registros dos editores, páginas DOI e o preprint aberto no arXiv</a:t>
             </a:r>
           </a:p>
         </p:txBody>
@@ -4472,7 +4472,7 @@
                 </a:solidFill>
                 <a:latin typeface="Arial"/>
               </a:rPr>
-              <a:t>AC4  |  CONTEXT</a:t>
+              <a:t>AC4  |  CONTEXTO</a:t>
             </a:r>
           </a:p>
         </p:txBody>
@@ -4507,7 +4507,7 @@
                 </a:solidFill>
                 <a:latin typeface="Arial"/>
               </a:rPr>
-              <a:t>One signal is not enough to monitor a hive</a:t>
+              <a:t>Monitorar a colmeia exige várias variáveis</a:t>
             </a:r>
           </a:p>
         </p:txBody>
@@ -4622,7 +4622,7 @@
                 </a:solidFill>
                 <a:latin typeface="Arial"/>
               </a:rPr>
-              <a:t>The literature supports a multimodal view of the colony.</a:t>
+              <a:t>A literatura sustenta uma visão multimodal da colônia.</a:t>
             </a:r>
           </a:p>
         </p:txBody>
@@ -4702,7 +4702,7 @@
                 </a:solidFill>
                 <a:latin typeface="Arial"/>
               </a:rPr>
-              <a:t>01  CONTEXT</a:t>
+              <a:t>01  CONTEXTO</a:t>
             </a:r>
           </a:p>
         </p:txBody>
@@ -4731,13 +4731,13 @@
           <a:p>
             <a:pPr algn="l"/>
             <a:r>
-              <a:rPr sz="2000" b="0" i="0">
+              <a:rPr sz="1800" b="0" i="0">
                 <a:solidFill>
                   <a:srgbClr val="121418"/>
                 </a:solidFill>
                 <a:latin typeface="Arial"/>
               </a:rPr>
-              <a:t>Manual inspections are intermittent and may disturb the colony when the hive is opened repeatedly.</a:t>
+              <a:t>Inspeções manuais são pontuais e podem perturbar a colônia ao abrir a colmeia.</a:t>
             </a:r>
           </a:p>
         </p:txBody>
@@ -4817,7 +4817,7 @@
                 </a:solidFill>
                 <a:latin typeface="Arial"/>
               </a:rPr>
-              <a:t>02  DATA PIPELINE</a:t>
+              <a:t>02  PIPELINE DE DADOS</a:t>
             </a:r>
           </a:p>
         </p:txBody>
@@ -4846,13 +4846,13 @@
           <a:p>
             <a:pPr algn="l"/>
             <a:r>
-              <a:rPr sz="2000" b="0" i="0">
+              <a:rPr sz="1800" b="0" i="0">
                 <a:solidFill>
                   <a:srgbClr val="121418"/>
                 </a:solidFill>
                 <a:latin typeface="Arial"/>
               </a:rPr>
-              <a:t>IoT systems connect environmental sensors, audio/video capture, wireless communication and remote storage.</a:t>
+              <a:t>Sistemas IoT conectam sensores, áudio/vídeo, comunicação sem fio e armazenamento remoto.</a:t>
             </a:r>
           </a:p>
         </p:txBody>
@@ -4932,7 +4932,7 @@
                 </a:solidFill>
                 <a:latin typeface="Arial"/>
               </a:rPr>
-              <a:t>03  RESEARCH GAP</a:t>
+              <a:t>03  LACUNA DE PESQUISA</a:t>
             </a:r>
           </a:p>
         </p:txBody>
@@ -4961,13 +4961,13 @@
           <a:p>
             <a:pPr algn="l"/>
             <a:r>
-              <a:rPr sz="2000" b="0" i="0">
+              <a:rPr sz="1800" b="0" i="0">
                 <a:solidFill>
                   <a:srgbClr val="121418"/>
                 </a:solidFill>
                 <a:latin typeface="Arial"/>
               </a:rPr>
-              <a:t>Signals are promising, but thresholds, metrics and cross-colony validation are not standardized.</a:t>
+              <a:t>Sinais promissores, mas limiares, métricas e validação entre colônias não são padronizados.</a:t>
             </a:r>
           </a:p>
         </p:txBody>
@@ -5002,7 +5002,7 @@
                 </a:solidFill>
                 <a:latin typeface="Arial"/>
               </a:rPr>
-              <a:t>Project direction: combine DHT11 measurements, entrance imaging and wireless data collection; treat audio, vibration and event detection as validation-dependent extensions.</a:t>
+              <a:t>Direção do projeto: combinar medições do DHT11, imagens da entrada e coleta sem fio; tratar áudio, vibração e detecção de eventos como extensões dependentes de validação.</a:t>
             </a:r>
           </a:p>
         </p:txBody>
@@ -5082,7 +5082,7 @@
                 </a:solidFill>
                 <a:latin typeface="Arial"/>
               </a:rPr>
-              <a:t>Fontes: [1]--[6], as listed in references.bib</a:t>
+              <a:t>Fontes: [1]--[6], conforme listadas no references.bib</a:t>
             </a:r>
           </a:p>
         </p:txBody>
@@ -5213,7 +5213,7 @@
                 </a:solidFill>
                 <a:latin typeface="Arial"/>
               </a:rPr>
-              <a:t>Zheng et al. connect hive conditions to activity</a:t>
+              <a:t>Zheng: ambiente e atividade da colmeia</a:t>
             </a:r>
           </a:p>
         </p:txBody>
@@ -5328,7 +5328,7 @@
                 </a:solidFill>
                 <a:latin typeface="Arial"/>
               </a:rPr>
-              <a:t>APPROACH</a:t>
+              <a:t>ABORDAGEM</a:t>
             </a:r>
           </a:p>
         </p:txBody>
@@ -5367,7 +5367,7 @@
               </a:defRPr>
             </a:pPr>
             <a:r>
-              <a:t>Temperature and humidity at center, margin, entrance and outside.</a:t>
+              <a:t>Temperatura e umidade no centro, margem, entrada e ambiente externo.</a:t>
             </a:r>
           </a:p>
           <a:p>
@@ -5383,7 +5383,7 @@
               </a:defRPr>
             </a:pPr>
             <a:r>
-              <a:t>Internal sound sensor plus entrance-facing webcam.</a:t>
+              <a:t>Sensor de som interno e webcam voltada para a entrada.</a:t>
             </a:r>
           </a:p>
           <a:p>
@@ -5399,7 +5399,7 @@
               </a:defRPr>
             </a:pPr>
             <a:r>
-              <a:t>YOLOv5 + DeepSORT for multi-bee tracking.</a:t>
+              <a:t>YOLOv5 + DeepSORT para rastrear várias abelhas.</a:t>
             </a:r>
           </a:p>
         </p:txBody>
@@ -5434,7 +5434,7 @@
                 </a:solidFill>
                 <a:latin typeface="Arial"/>
               </a:rPr>
-              <a:t>QUALITATIVE TAKEAWAY</a:t>
+              <a:t>SÍNTESE QUALITATIVA</a:t>
             </a:r>
           </a:p>
         </p:txBody>
@@ -5469,7 +5469,7 @@
                 </a:solidFill>
                 <a:latin typeface="Arial"/>
               </a:rPr>
-              <a:t>A strong example of multimodal IoT monitoring: environmental measurements are interpreted together with entrance activity and internal sound.</a:t>
+              <a:t>Exemplo forte de monitoramento IoT multimodal: medidas ambientais são interpretadas junto à atividade na entrada e ao som interno.</a:t>
             </a:r>
           </a:p>
         </p:txBody>
@@ -5549,7 +5549,7 @@
                 </a:solidFill>
                 <a:latin typeface="Arial"/>
               </a:rPr>
-              <a:t>QUANTITATIVE EVIDENCE</a:t>
+              <a:t>EVIDÊNCIAS QUANTITATIVAS</a:t>
             </a:r>
           </a:p>
         </p:txBody>
@@ -5629,7 +5629,7 @@
                 </a:solidFill>
                 <a:latin typeface="Arial"/>
               </a:rPr>
-              <a:t>83.5 ± 0.7</a:t>
+              <a:t>83,5 ± 0,7</a:t>
             </a:r>
           </a:p>
         </p:txBody>
@@ -5744,7 +5744,7 @@
                 </a:solidFill>
                 <a:latin typeface="Arial"/>
               </a:rPr>
-              <a:t>77.3 ± 0.2</a:t>
+              <a:t>77,3 ± 0,2</a:t>
             </a:r>
           </a:p>
         </p:txBody>
@@ -5894,7 +5894,7 @@
                 </a:solidFill>
                 <a:latin typeface="Arial"/>
               </a:rPr>
-              <a:t>maximum reported rate</a:t>
+              <a:t>taxa máxima relatada</a:t>
             </a:r>
           </a:p>
         </p:txBody>
@@ -6009,7 +6009,7 @@
                 </a:solidFill>
                 <a:latin typeface="Arial"/>
               </a:rPr>
-              <a:t>center temperature range</a:t>
+              <a:t>faixa de temperatura central</a:t>
             </a:r>
           </a:p>
         </p:txBody>
@@ -6044,7 +6044,7 @@
                 </a:solidFill>
                 <a:latin typeface="Arial"/>
               </a:rPr>
-              <a:t>PROJECT IMPLICATION</a:t>
+              <a:t>IMPLICAÇÃO PARA O PROJETO</a:t>
             </a:r>
           </a:p>
         </p:txBody>
@@ -6079,7 +6079,7 @@
                 </a:solidFill>
                 <a:latin typeface="Arial"/>
               </a:rPr>
-              <a:t>Supports the sensor distribution, entrance camera and multimodal architecture. The reported environmental ranges are evidence from one study, not universal thresholds.</a:t>
+              <a:t>Sustenta a distribuição dos sensores, a câmera na entrada e a arquitetura multimodal. As faixas ambientais vêm de um estudo e não são limiares universais.</a:t>
             </a:r>
           </a:p>
         </p:txBody>
@@ -6290,7 +6290,7 @@
                 </a:solidFill>
                 <a:latin typeface="Arial"/>
               </a:rPr>
-              <a:t>IntelliBeeHive: low-cost vision with clear limits</a:t>
+              <a:t>IntelliBeeHive: visão de baixo custo</a:t>
             </a:r>
           </a:p>
         </p:txBody>
@@ -6405,7 +6405,7 @@
                 </a:solidFill>
                 <a:latin typeface="Arial"/>
               </a:rPr>
-              <a:t>APPROACH</a:t>
+              <a:t>ABORDAGEM</a:t>
             </a:r>
           </a:p>
         </p:txBody>
@@ -6444,7 +6444,7 @@
               </a:defRPr>
             </a:pPr>
             <a:r>
-              <a:t>Entrance-facing camera and account-based remote monitoring.</a:t>
+              <a:t>Câmera voltada para a entrada e monitoramento remoto.</a:t>
             </a:r>
           </a:p>
           <a:p>
@@ -6460,7 +6460,7 @@
               </a:defRPr>
             </a:pPr>
             <a:r>
-              <a:t>YOLOv7-tiny models for bees, pollen and mites.</a:t>
+              <a:t>Modelos YOLOv7-tiny para abelhas, pólen e ácaros.</a:t>
             </a:r>
           </a:p>
           <a:p>
@@ -6476,7 +6476,7 @@
               </a:defRPr>
             </a:pPr>
             <a:r>
-              <a:t>Designed for low-cost, real-time observation.</a:t>
+              <a:t>Projetado para observação de baixo custo em tempo real.</a:t>
             </a:r>
           </a:p>
         </p:txBody>
@@ -6511,7 +6511,7 @@
                 </a:solidFill>
                 <a:latin typeface="Arial"/>
               </a:rPr>
-              <a:t>QUALITATIVE TAKEAWAY</a:t>
+              <a:t>SÍNTESE QUALITATIVA</a:t>
             </a:r>
           </a:p>
         </p:txBody>
@@ -6546,7 +6546,7 @@
                 </a:solidFill>
                 <a:latin typeface="Arial"/>
               </a:rPr>
-              <a:t>The paper demonstrates that lightweight computer vision can monitor the hive entrance without disturbing the colony, but the Varroa result must remain a proof of concept.</a:t>
+              <a:t>O artigo mostra que a visão computacional leve pode monitorar a entrada sem perturbar a colônia, mas o resultado de Varroa deve permanecer como prova de conceito.</a:t>
             </a:r>
           </a:p>
         </p:txBody>
@@ -6626,7 +6626,7 @@
                 </a:solidFill>
                 <a:latin typeface="Arial"/>
               </a:rPr>
-              <a:t>QUANTITATIVE EVIDENCE</a:t>
+              <a:t>EVIDÊNCIAS QUANTITATIVAS</a:t>
             </a:r>
           </a:p>
         </p:txBody>
@@ -6706,7 +6706,7 @@
                 </a:solidFill>
                 <a:latin typeface="Arial"/>
               </a:rPr>
-              <a:t>96.28%</a:t>
+              <a:t>96,28%</a:t>
             </a:r>
           </a:p>
         </p:txBody>
@@ -6741,7 +6741,7 @@
                 </a:solidFill>
                 <a:latin typeface="Arial"/>
               </a:rPr>
-              <a:t>tracking accuracy</a:t>
+              <a:t>acurácia do rastreamento</a:t>
             </a:r>
           </a:p>
         </p:txBody>
@@ -6821,7 +6821,7 @@
                 </a:solidFill>
                 <a:latin typeface="Arial"/>
               </a:rPr>
-              <a:t>0.8319</a:t>
+              <a:t>0,8319</a:t>
             </a:r>
           </a:p>
         </p:txBody>
@@ -6856,7 +6856,7 @@
                 </a:solidFill>
                 <a:latin typeface="Arial"/>
               </a:rPr>
-              <a:t>pollen F1-score</a:t>
+              <a:t>F1 do pólen</a:t>
             </a:r>
           </a:p>
         </p:txBody>
@@ -6971,7 +6971,7 @@
                 </a:solidFill>
                 <a:latin typeface="Arial"/>
               </a:rPr>
-              <a:t>tiny variant</a:t>
+              <a:t>variante tiny</a:t>
             </a:r>
           </a:p>
         </p:txBody>
@@ -7051,7 +7051,7 @@
                 </a:solidFill>
                 <a:latin typeface="Arial"/>
               </a:rPr>
-              <a:t>Limited</a:t>
+              <a:t>Limitados</a:t>
             </a:r>
           </a:p>
         </p:txBody>
@@ -7086,7 +7086,7 @@
                 </a:solidFill>
                 <a:latin typeface="Arial"/>
               </a:rPr>
-              <a:t>mite data</a:t>
+              <a:t>dados de ácaros</a:t>
             </a:r>
           </a:p>
         </p:txBody>
@@ -7121,7 +7121,7 @@
                 </a:solidFill>
                 <a:latin typeface="Arial"/>
               </a:rPr>
-              <a:t>PROJECT IMPLICATION</a:t>
+              <a:t>IMPLICAÇÃO PARA O PROJETO</a:t>
             </a:r>
           </a:p>
         </p:txBody>
@@ -7156,7 +7156,7 @@
                 </a:solidFill>
                 <a:latin typeface="Arial"/>
               </a:rPr>
-              <a:t>Supports the ESP32-CAM / lightweight-model direction. Pollen and Varroa require representative labeled data before being treated as reliable outputs.</a:t>
+              <a:t>Sustenta o uso do ESP32-CAM e de modelos leves. Pólen e Varroa exigem dados rotulados e representativos antes de serem saídas confiáveis.</a:t>
             </a:r>
           </a:p>
         </p:txBody>
@@ -7367,7 +7367,7 @@
                 </a:solidFill>
                 <a:latin typeface="Arial"/>
               </a:rPr>
-              <a:t>Acoustic sensing lacks standard metrics</a:t>
+              <a:t>Acústica: faltam métricas padrão</a:t>
             </a:r>
           </a:p>
         </p:txBody>
@@ -7482,7 +7482,7 @@
                 </a:solidFill>
                 <a:latin typeface="Arial"/>
               </a:rPr>
-              <a:t>APPROACH</a:t>
+              <a:t>ABORDAGEM</a:t>
             </a:r>
           </a:p>
         </p:txBody>
@@ -7521,7 +7521,7 @@
               </a:defRPr>
             </a:pPr>
             <a:r>
-              <a:t>Review of microphones and accelerometers for beekeeping.</a:t>
+              <a:t>Revisão de microfones e acelerômetros aplicados à apicultura.</a:t>
             </a:r>
           </a:p>
           <a:p>
@@ -7537,7 +7537,7 @@
               </a:defRPr>
             </a:pPr>
             <a:r>
-              <a:t>Focus on queen presence and swarming-related states.</a:t>
+              <a:t>Foco na presença da rainha e em estados ligados à enxameação.</a:t>
             </a:r>
           </a:p>
           <a:p>
@@ -7553,7 +7553,7 @@
               </a:defRPr>
             </a:pPr>
             <a:r>
-              <a:t>Signals can be collected without opening the hive.</a:t>
+              <a:t>Sinais coletados sem abrir a colmeia.</a:t>
             </a:r>
           </a:p>
         </p:txBody>
@@ -7588,7 +7588,7 @@
                 </a:solidFill>
                 <a:latin typeface="Arial"/>
               </a:rPr>
-              <a:t>QUALITATIVE TAKEAWAY</a:t>
+              <a:t>SÍNTESE QUALITATIVA</a:t>
             </a:r>
           </a:p>
         </p:txBody>
@@ -7623,7 +7623,7 @@
                 </a:solidFill>
                 <a:latin typeface="Arial"/>
               </a:rPr>
-              <a:t>The review supports acoustic and vibration monitoring as a complementary, non-invasive modality, while emphasizing that results are difficult to compare across colonies and studies.</a:t>
+              <a:t>A revisão apoia o monitoramento acústico e vibracional como modalidade complementar e não invasiva, mas destaca a dificuldade de comparar resultados entre colônias e estudos.</a:t>
             </a:r>
           </a:p>
         </p:txBody>
@@ -7703,7 +7703,7 @@
                 </a:solidFill>
                 <a:latin typeface="Arial"/>
               </a:rPr>
-              <a:t>QUANTITATIVE EVIDENCE</a:t>
+              <a:t>EVIDÊNCIAS QUANTITATIVAS</a:t>
             </a:r>
           </a:p>
         </p:txBody>
@@ -7818,7 +7818,7 @@
                 </a:solidFill>
                 <a:latin typeface="Arial"/>
               </a:rPr>
-              <a:t>pooled score</a:t>
+              <a:t>pontuação agregada</a:t>
             </a:r>
           </a:p>
         </p:txBody>
@@ -7898,7 +7898,7 @@
                 </a:solidFill>
                 <a:latin typeface="Arial"/>
               </a:rPr>
-              <a:t>Small</a:t>
+              <a:t>Pequenos</a:t>
             </a:r>
           </a:p>
         </p:txBody>
@@ -7933,7 +7933,7 @@
                 </a:solidFill>
                 <a:latin typeface="Arial"/>
               </a:rPr>
-              <a:t>datasets</a:t>
+              <a:t>conjuntos de dados</a:t>
             </a:r>
           </a:p>
         </p:txBody>
@@ -8013,7 +8013,7 @@
                 </a:solidFill>
                 <a:latin typeface="Arial"/>
               </a:rPr>
-              <a:t>No</a:t>
+              <a:t>Não há</a:t>
             </a:r>
           </a:p>
         </p:txBody>
@@ -8048,7 +8048,7 @@
                 </a:solidFill>
                 <a:latin typeface="Arial"/>
               </a:rPr>
-              <a:t>common metrics</a:t>
+              <a:t>métricas comuns</a:t>
             </a:r>
           </a:p>
         </p:txBody>
@@ -8128,7 +8128,7 @@
                 </a:solidFill>
                 <a:latin typeface="Arial"/>
               </a:rPr>
-              <a:t>Low</a:t>
+              <a:t>Baixa</a:t>
             </a:r>
           </a:p>
         </p:txBody>
@@ -8163,7 +8163,7 @@
                 </a:solidFill>
                 <a:latin typeface="Arial"/>
               </a:rPr>
-              <a:t>generalizability</a:t>
+              <a:t>generalização</a:t>
             </a:r>
           </a:p>
         </p:txBody>
@@ -8198,7 +8198,7 @@
                 </a:solidFill>
                 <a:latin typeface="Arial"/>
               </a:rPr>
-              <a:t>PROJECT IMPLICATION</a:t>
+              <a:t>IMPLICAÇÃO PARA O PROJETO</a:t>
             </a:r>
           </a:p>
         </p:txBody>
@@ -8233,7 +8233,7 @@
                 </a:solidFill>
                 <a:latin typeface="Arial"/>
               </a:rPr>
-              <a:t>The project should preserve signal context and document feature extraction. The KY-038 can only be an initial noise indicator; reliable recording needs a suitable microphone.</a:t>
+              <a:t>Preservar o contexto do sinal e documentar as características. O KY-038 é apenas um indicador de ruído; gravações confiáveis exigem microfone adequado.</a:t>
             </a:r>
           </a:p>
         </p:txBody>
@@ -8444,7 +8444,7 @@
                 </a:solidFill>
                 <a:latin typeface="Arial"/>
               </a:rPr>
-              <a:t>Beemon builds a remote monitoring pipeline</a:t>
+              <a:t>Beemon: pipeline remoto de monitoramento</a:t>
             </a:r>
           </a:p>
         </p:txBody>
@@ -8559,7 +8559,7 @@
                 </a:solidFill>
                 <a:latin typeface="Arial"/>
               </a:rPr>
-              <a:t>APPROACH</a:t>
+              <a:t>ABORDAGEM</a:t>
             </a:r>
           </a:p>
         </p:txBody>
@@ -8598,7 +8598,7 @@
               </a:defRPr>
             </a:pPr>
             <a:r>
-              <a:t>Temperature, humidity, weight, audio and video capture.</a:t>
+              <a:t>Captura de temperatura, umidade, peso, áudio e vídeo.</a:t>
             </a:r>
           </a:p>
           <a:p>
@@ -8614,7 +8614,7 @@
               </a:defRPr>
             </a:pPr>
             <a:r>
-              <a:t>MQTT to ThingsBoard and remote server storage.</a:t>
+              <a:t>MQTT para ThingsBoard e armazenamento em servidor remoto.</a:t>
             </a:r>
           </a:p>
           <a:p>
@@ -8630,7 +8630,7 @@
               </a:defRPr>
             </a:pPr>
             <a:r>
-              <a:t>Continuous operation in an outdoor apiary.</a:t>
+              <a:t>Operação contínua em apiário externo.</a:t>
             </a:r>
           </a:p>
         </p:txBody>
@@ -8665,7 +8665,7 @@
                 </a:solidFill>
                 <a:latin typeface="Arial"/>
               </a:rPr>
-              <a:t>QUALITATIVE TAKEAWAY</a:t>
+              <a:t>SÍNTESE QUALITATIVA</a:t>
             </a:r>
           </a:p>
         </p:txBody>
@@ -8700,7 +8700,7 @@
                 </a:solidFill>
                 <a:latin typeface="Arial"/>
               </a:rPr>
-              <a:t>Beemon focuses on reliable data acquisition and remote access. Its contribution is the end-to-end monitoring infrastructure rather than a fully validated colony-health classifier.</a:t>
+              <a:t>O Beemon prioriza aquisição confiável e acesso remoto aos dados. Sua contribuição é a infraestrutura ponta a ponta, não um classificador de saúde da colônia plenamente validado.</a:t>
             </a:r>
           </a:p>
         </p:txBody>
@@ -8780,7 +8780,7 @@
                 </a:solidFill>
                 <a:latin typeface="Arial"/>
               </a:rPr>
-              <a:t>QUANTITATIVE EVIDENCE</a:t>
+              <a:t>EVIDÊNCIAS QUANTITATIVAS</a:t>
             </a:r>
           </a:p>
         </p:txBody>
@@ -8860,7 +8860,7 @@
                 </a:solidFill>
                 <a:latin typeface="Arial"/>
               </a:rPr>
-              <a:t>44.1 kHz+</a:t>
+              <a:t>44,1 kHz+</a:t>
             </a:r>
           </a:p>
         </p:txBody>
@@ -8895,7 +8895,7 @@
                 </a:solidFill>
                 <a:latin typeface="Arial"/>
               </a:rPr>
-              <a:t>audio capability</a:t>
+              <a:t>capacidade de áudio</a:t>
             </a:r>
           </a:p>
         </p:txBody>
@@ -8975,7 +8975,7 @@
                 </a:solidFill>
                 <a:latin typeface="Arial"/>
               </a:rPr>
-              <a:t>Near-real</a:t>
+              <a:t>Quase real</a:t>
             </a:r>
           </a:p>
         </p:txBody>
@@ -9010,7 +9010,7 @@
                 </a:solidFill>
                 <a:latin typeface="Arial"/>
               </a:rPr>
-              <a:t>time collection</a:t>
+              <a:t>tempo de coleta</a:t>
             </a:r>
           </a:p>
         </p:txBody>
@@ -9090,7 +9090,7 @@
                 </a:solidFill>
                 <a:latin typeface="Arial"/>
               </a:rPr>
-              <a:t>Outdoor</a:t>
+              <a:t>Externa</a:t>
             </a:r>
           </a:p>
         </p:txBody>
@@ -9125,7 +9125,7 @@
                 </a:solidFill>
                 <a:latin typeface="Arial"/>
               </a:rPr>
-              <a:t>continuous operation</a:t>
+              <a:t>operação contínua</a:t>
             </a:r>
           </a:p>
         </p:txBody>
@@ -9205,7 +9205,7 @@
                 </a:solidFill>
                 <a:latin typeface="Arial"/>
               </a:rPr>
-              <a:t>Limited</a:t>
+              <a:t>Limitados</a:t>
             </a:r>
           </a:p>
         </p:txBody>
@@ -9240,7 +9240,7 @@
                 </a:solidFill>
                 <a:latin typeface="Arial"/>
               </a:rPr>
-              <a:t>field results</a:t>
+              <a:t>resultados de campo</a:t>
             </a:r>
           </a:p>
         </p:txBody>
@@ -9275,7 +9275,7 @@
                 </a:solidFill>
                 <a:latin typeface="Arial"/>
               </a:rPr>
-              <a:t>PROJECT IMPLICATION</a:t>
+              <a:t>IMPLICAÇÃO PARA O PROJETO</a:t>
             </a:r>
           </a:p>
         </p:txBody>
@@ -9310,7 +9310,7 @@
                 </a:solidFill>
                 <a:latin typeface="Arial"/>
               </a:rPr>
-              <a:t>Supports MQTT, timestamped records, remote visualization and a separation between embedded capture and heavier analysis on a server.</a:t>
+              <a:t>Sustenta o uso de MQTT, registros com marca temporal, visualização remota e separação entre captura embarcada e análise mais pesada no servidor.</a:t>
             </a:r>
           </a:p>
         </p:txBody>
@@ -9521,7 +9521,7 @@
                 </a:solidFill>
                 <a:latin typeface="Arial"/>
               </a:rPr>
-              <a:t>Wireless sensing can monitor hive conditions</a:t>
+              <a:t>Sensoriamento sem fio monitora a colmeia</a:t>
             </a:r>
           </a:p>
         </p:txBody>
@@ -9636,7 +9636,7 @@
                 </a:solidFill>
                 <a:latin typeface="Arial"/>
               </a:rPr>
-              <a:t>APPROACH</a:t>
+              <a:t>ABORDAGEM</a:t>
             </a:r>
           </a:p>
         </p:txBody>
@@ -9675,7 +9675,7 @@
               </a:defRPr>
             </a:pPr>
             <a:r>
-              <a:t>Wireless network for in-hive temperature, relative humidity and sound.</a:t>
+              <a:t>Rede sem fio para temperatura, umidade relativa e som dentro da colmeia.</a:t>
             </a:r>
           </a:p>
           <a:p>
@@ -9691,7 +9691,7 @@
               </a:defRPr>
             </a:pPr>
             <a:r>
-              <a:t>Wi-Fi evaluated in an apiary environment.</a:t>
+              <a:t>Wi-Fi avaliado em ambiente de apiário.</a:t>
             </a:r>
           </a:p>
           <a:p>
@@ -9707,7 +9707,7 @@
               </a:defRPr>
             </a:pPr>
             <a:r>
-              <a:t>Signals interpreted in relation to stress and swarming.</a:t>
+              <a:t>Sinais interpretados em relação a estresse e enxameação.</a:t>
             </a:r>
           </a:p>
         </p:txBody>
@@ -9742,7 +9742,7 @@
                 </a:solidFill>
                 <a:latin typeface="Arial"/>
               </a:rPr>
-              <a:t>QUALITATIVE TAKEAWAY</a:t>
+              <a:t>SÍNTESE QUALITATIVA</a:t>
             </a:r>
           </a:p>
         </p:txBody>
@@ -9777,7 +9777,7 @@
                 </a:solidFill>
                 <a:latin typeface="Arial"/>
               </a:rPr>
-              <a:t>The study provides evidence that wireless collection is practical, while also warning that radio-frequency effects and hive dynamics require continued evaluation.</a:t>
+              <a:t>O estudo indica que a coleta sem fio é viável, mas alerta que efeitos de radiofrequência e dinâmica da colmeia exigem avaliação contínua.</a:t>
             </a:r>
           </a:p>
         </p:txBody>
@@ -9857,7 +9857,7 @@
                 </a:solidFill>
                 <a:latin typeface="Arial"/>
               </a:rPr>
-              <a:t>QUANTITATIVE EVIDENCE</a:t>
+              <a:t>EVIDÊNCIAS QUANTITATIVAS</a:t>
             </a:r>
           </a:p>
         </p:txBody>
@@ -9937,7 +9937,7 @@
                 </a:solidFill>
                 <a:latin typeface="Arial"/>
               </a:rPr>
-              <a:t>6 hives</a:t>
+              <a:t>6 colmeias</a:t>
             </a:r>
           </a:p>
         </p:txBody>
@@ -9972,7 +9972,7 @@
                 </a:solidFill>
                 <a:latin typeface="Arial"/>
               </a:rPr>
-              <a:t>study scale</a:t>
+              <a:t>escala do estudo</a:t>
             </a:r>
           </a:p>
         </p:txBody>
@@ -10052,7 +10052,7 @@
                 </a:solidFill>
                 <a:latin typeface="Arial"/>
               </a:rPr>
-              <a:t>30 days</a:t>
+              <a:t>30 dias</a:t>
             </a:r>
           </a:p>
         </p:txBody>
@@ -10087,7 +10087,7 @@
                 </a:solidFill>
                 <a:latin typeface="Arial"/>
               </a:rPr>
-              <a:t>observation period</a:t>
+              <a:t>período de observação</a:t>
             </a:r>
           </a:p>
         </p:txBody>
@@ -10167,7 +10167,7 @@
                 </a:solidFill>
                 <a:latin typeface="Arial"/>
               </a:rPr>
-              <a:t>No change</a:t>
+              <a:t>Nenhuma</a:t>
             </a:r>
           </a:p>
         </p:txBody>
@@ -10202,7 +10202,7 @@
                 </a:solidFill>
                 <a:latin typeface="Arial"/>
               </a:rPr>
-              <a:t>Wi-Fi effect</a:t>
+              <a:t>alteração com Wi-Fi</a:t>
             </a:r>
           </a:p>
         </p:txBody>
@@ -10282,7 +10282,7 @@
                 </a:solidFill>
                 <a:latin typeface="Arial"/>
               </a:rPr>
-              <a:t>Real-time</a:t>
+              <a:t>Tempo real</a:t>
             </a:r>
           </a:p>
         </p:txBody>
@@ -10317,7 +10317,7 @@
                 </a:solidFill>
                 <a:latin typeface="Arial"/>
               </a:rPr>
-              <a:t>monitoring potential</a:t>
+              <a:t>potencial de monitoramento</a:t>
             </a:r>
           </a:p>
         </p:txBody>
@@ -10352,7 +10352,7 @@
                 </a:solidFill>
                 <a:latin typeface="Arial"/>
               </a:rPr>
-              <a:t>PROJECT IMPLICATION</a:t>
+              <a:t>IMPLICAÇÃO PARA O PROJETO</a:t>
             </a:r>
           </a:p>
         </p:txBody>
@@ -10387,7 +10387,7 @@
                 </a:solidFill>
                 <a:latin typeface="Arial"/>
               </a:rPr>
-              <a:t>Supports Wi-Fi as the first communication option when coverage exists. The final deployment still needs testing for range, power and environmental stability.</a:t>
+              <a:t>Sustenta o Wi-Fi como primeira opção de comunicação quando houver cobertura. A implantação ainda precisa testar alcance, consumo e estabilidade ambiental.</a:t>
             </a:r>
           </a:p>
         </p:txBody>
@@ -10598,7 +10598,7 @@
                 </a:solidFill>
                 <a:latin typeface="Arial"/>
               </a:rPr>
-              <a:t>Raspberry Pi enables entrance monitoring</a:t>
+              <a:t>Raspberry Pi monitora a entrada</a:t>
             </a:r>
           </a:p>
         </p:txBody>
@@ -10713,7 +10713,7 @@
                 </a:solidFill>
                 <a:latin typeface="Arial"/>
               </a:rPr>
-              <a:t>APPROACH</a:t>
+              <a:t>ABORDAGEM</a:t>
             </a:r>
           </a:p>
         </p:txBody>
@@ -10752,7 +10752,7 @@
               </a:defRPr>
             </a:pPr>
             <a:r>
-              <a:t>Low-cost Raspberry Pi video system at the hive entrance.</a:t>
+              <a:t>Sistema de vídeo de baixo custo na entrada da colmeia.</a:t>
             </a:r>
           </a:p>
           <a:p>
@@ -10768,7 +10768,7 @@
               </a:defRPr>
             </a:pPr>
             <a:r>
-              <a:t>Background subtraction for segmentation.</a:t>
+              <a:t>Subtração de fundo para segmentação.</a:t>
             </a:r>
           </a:p>
           <a:p>
@@ -10784,7 +10784,7 @@
               </a:defRPr>
             </a:pPr>
             <a:r>
-              <a:t>Counts bees, identifies position and measures in/out activity.</a:t>
+              <a:t>Conta abelhas, identifica posições e mede atividade de entrada e saída.</a:t>
             </a:r>
           </a:p>
         </p:txBody>
@@ -10819,7 +10819,7 @@
                 </a:solidFill>
                 <a:latin typeface="Arial"/>
               </a:rPr>
-              <a:t>QUALITATIVE TAKEAWAY</a:t>
+              <a:t>SÍNTESE QUALITATIVA</a:t>
             </a:r>
           </a:p>
         </p:txBody>
@@ -10854,7 +10854,7 @@
                 </a:solidFill>
                 <a:latin typeface="Arial"/>
               </a:rPr>
-              <a:t>Tu et al. show that entrance behavior can be estimated with a lightweight embedded platform, using manual counts as the reference for evaluation.</a:t>
+              <a:t>Tu et al. mostram que o comportamento na entrada pode ser estimado com uma plataforma embarcada leve, usando contagens manuais como referência.</a:t>
             </a:r>
           </a:p>
         </p:txBody>
@@ -10934,7 +10934,7 @@
                 </a:solidFill>
                 <a:latin typeface="Arial"/>
               </a:rPr>
-              <a:t>QUANTITATIVE EVIDENCE</a:t>
+              <a:t>EVIDÊNCIAS QUANTITATIVAS</a:t>
             </a:r>
           </a:p>
         </p:txBody>
@@ -11014,7 +11014,7 @@
                 </a:solidFill>
                 <a:latin typeface="Arial"/>
               </a:rPr>
-              <a:t>0.987</a:t>
+              <a:t>0,987</a:t>
             </a:r>
           </a:p>
         </p:txBody>
@@ -11049,7 +11049,7 @@
                 </a:solidFill>
                 <a:latin typeface="Arial"/>
               </a:rPr>
-              <a:t>R²: bee count</a:t>
+              <a:t>R²: contagem</a:t>
             </a:r>
           </a:p>
         </p:txBody>
@@ -11129,7 +11129,7 @@
                 </a:solidFill>
                 <a:latin typeface="Arial"/>
               </a:rPr>
-              <a:t>0.953</a:t>
+              <a:t>0,953</a:t>
             </a:r>
           </a:p>
         </p:txBody>
@@ -11164,7 +11164,7 @@
                 </a:solidFill>
                 <a:latin typeface="Arial"/>
               </a:rPr>
-              <a:t>R²: in-activity</a:t>
+              <a:t>R²: atividade de entrada</a:t>
             </a:r>
           </a:p>
         </p:txBody>
@@ -11244,7 +11244,7 @@
                 </a:solidFill>
                 <a:latin typeface="Arial"/>
               </a:rPr>
-              <a:t>0.888</a:t>
+              <a:t>0,888</a:t>
             </a:r>
           </a:p>
         </p:txBody>
@@ -11279,7 +11279,7 @@
                 </a:solidFill>
                 <a:latin typeface="Arial"/>
               </a:rPr>
-              <a:t>R²: out-activity</a:t>
+              <a:t>R²: atividade de saída</a:t>
             </a:r>
           </a:p>
         </p:txBody>
@@ -11359,7 +11359,7 @@
                 </a:solidFill>
                 <a:latin typeface="Arial"/>
               </a:rPr>
-              <a:t>Real-time</a:t>
+              <a:t>Tempo real</a:t>
             </a:r>
           </a:p>
         </p:txBody>
@@ -11394,7 +11394,7 @@
                 </a:solidFill>
                 <a:latin typeface="Arial"/>
               </a:rPr>
-              <a:t>processing viable</a:t>
+              <a:t>processamento viável</a:t>
             </a:r>
           </a:p>
         </p:txBody>
@@ -11429,7 +11429,7 @@
                 </a:solidFill>
                 <a:latin typeface="Arial"/>
               </a:rPr>
-              <a:t>PROJECT IMPLICATION</a:t>
+              <a:t>IMPLICAÇÃO PARA O PROJETO</a:t>
             </a:r>
           </a:p>
         </p:txBody>
@@ -11464,7 +11464,7 @@
                 </a:solidFill>
                 <a:latin typeface="Arial"/>
               </a:rPr>
-              <a:t>Supports low-cost entrance imaging and objective validation. The method must be retested under our camera position, lighting and entrance geometry.</a:t>
+              <a:t>Sustenta imagens de baixo custo na entrada e validação objetiva. O método deve ser retestado com nossa posição de câmera, iluminação e geometria da entrada.</a:t>
             </a:r>
           </a:p>
         </p:txBody>
@@ -11640,7 +11640,7 @@
                 </a:solidFill>
                 <a:latin typeface="Arial"/>
               </a:rPr>
-              <a:t>SYNTHESIS</a:t>
+              <a:t>SÍNTESE</a:t>
             </a:r>
           </a:p>
         </p:txBody>
@@ -11675,7 +11675,7 @@
                 </a:solidFill>
                 <a:latin typeface="Arial"/>
               </a:rPr>
-              <a:t>Six studies point to one practical architecture</a:t>
+              <a:t>Seis estudos apontam uma arquitetura prática</a:t>
             </a:r>
           </a:p>
         </p:txBody>
@@ -11790,7 +11790,7 @@
                 </a:solidFill>
                 <a:latin typeface="Arial"/>
               </a:rPr>
-              <a:t>WHAT THE LITERATURE SUPPORTS</a:t>
+              <a:t>O QUE A LITERATURA SUSTENTA</a:t>
             </a:r>
           </a:p>
         </p:txBody>
@@ -11829,7 +11829,7 @@
               </a:defRPr>
             </a:pPr>
             <a:r>
-              <a:t>Environmental sensing inside and outside the hive.</a:t>
+              <a:t>Sensoriamento ambiental dentro e fora da colmeia.</a:t>
             </a:r>
           </a:p>
           <a:p>
@@ -11845,7 +11845,7 @@
               </a:defRPr>
             </a:pPr>
             <a:r>
-              <a:t>Entrance-focused vision with lightweight processing.</a:t>
+              <a:t>Visão focada na entrada com processamento leve.</a:t>
             </a:r>
           </a:p>
           <a:p>
@@ -11861,7 +11861,7 @@
               </a:defRPr>
             </a:pPr>
             <a:r>
-              <a:t>Wireless transport, remote storage and visualization.</a:t>
+              <a:t>Transporte sem fio, armazenamento e visualização remotos.</a:t>
             </a:r>
           </a:p>
         </p:txBody>
@@ -11896,7 +11896,7 @@
                 </a:solidFill>
                 <a:latin typeface="Arial"/>
               </a:rPr>
-              <a:t>WHAT REMAINS OPEN</a:t>
+              <a:t>O QUE AINDA ESTÁ EM ABERTO</a:t>
             </a:r>
           </a:p>
         </p:txBody>
@@ -11935,7 +11935,7 @@
               </a:defRPr>
             </a:pPr>
             <a:r>
-              <a:t>No universal thresholds for colony state.</a:t>
+              <a:t>Não há limiares universais para o estado da colônia.</a:t>
             </a:r>
           </a:p>
           <a:p>
@@ -11951,7 +11951,7 @@
               </a:defRPr>
             </a:pPr>
             <a:r>
-              <a:t>Acoustic metrics and datasets are inconsistent.</a:t>
+              <a:t>Métricas e dados acústicos são inconsistentes.</a:t>
             </a:r>
           </a:p>
           <a:p>
@@ -11967,7 +11967,7 @@
               </a:defRPr>
             </a:pPr>
             <a:r>
-              <a:t>Varroa and event detection need field validation.</a:t>
+              <a:t>Varroa e eventos exigem validação em campo.</a:t>
             </a:r>
           </a:p>
         </p:txBody>
@@ -12002,7 +12002,7 @@
                 </a:solidFill>
                 <a:latin typeface="Arial"/>
               </a:rPr>
-              <a:t>OUR INITIAL SCOPE</a:t>
+              <a:t>ESCOPO INICIAL</a:t>
             </a:r>
           </a:p>
         </p:txBody>
@@ -12041,7 +12041,7 @@
               </a:defRPr>
             </a:pPr>
             <a:r>
-              <a:t>DHT11 + ESP32-CAM + wireless controller.</a:t>
+              <a:t>DHT11 + ESP32-CAM + controlador sem fio.</a:t>
             </a:r>
           </a:p>
           <a:p>
@@ -12057,7 +12057,7 @@
               </a:defRPr>
             </a:pPr>
             <a:r>
-              <a:t>Timestamped environmental and image data.</a:t>
+              <a:t>Dados ambientais e imagens com marca temporal.</a:t>
             </a:r>
           </a:p>
           <a:p>
@@ -12073,7 +12073,7 @@
               </a:defRPr>
             </a:pPr>
             <a:r>
-              <a:t>Audio/vibration as experimental extensions.</a:t>
+              <a:t>Áudio e vibração como extensões experimentais.</a:t>
             </a:r>
           </a:p>
         </p:txBody>
@@ -12153,7 +12153,7 @@
                 </a:solidFill>
                 <a:latin typeface="Arial"/>
               </a:rPr>
-              <a:t>Takeaway: the contribution is not a single sensor or model; it is a validated multimodal data pipeline for non-invasive hive monitoring.</a:t>
+              <a:t>Conclusão: a contribuição é um pipeline multimodal validado para monitoramento não invasivo de colmeias — não apenas um sensor ou modelo.</a:t>
             </a:r>
           </a:p>
         </p:txBody>
@@ -12233,7 +12233,7 @@
                 </a:solidFill>
                 <a:latin typeface="Arial"/>
               </a:rPr>
-              <a:t>Fontes: [1]--[6], as listed in references.bib</a:t>
+              <a:t>Fontes: [1]--[6], conforme listadas no references.bib</a:t>
             </a:r>
           </a:p>
         </p:txBody>

</xml_diff>